<commit_message>
update : ajout tous les fichiers 3 sites projet
</commit_message>
<xml_diff>
--- a/MoonWebsite/annexe/Presentation.pptx
+++ b/MoonWebsite/annexe/Presentation.pptx
@@ -3043,7 +3043,7 @@
           <a:p>
             <a:fld id="{E80C50CD-E178-4744-9B35-B2F624D6C5E9}" type="datetimeFigureOut">
               <a:rPr lang="en-US" smtClean="0"/>
-              <a:t>6/22/2026</a:t>
+              <a:t>6/23/2026</a:t>
             </a:fld>
             <a:endParaRPr lang="en-US"/>
           </a:p>
@@ -3241,7 +3241,7 @@
           <a:p>
             <a:fld id="{E80C50CD-E178-4744-9B35-B2F624D6C5E9}" type="datetimeFigureOut">
               <a:rPr lang="en-US" smtClean="0"/>
-              <a:t>6/22/2026</a:t>
+              <a:t>6/23/2026</a:t>
             </a:fld>
             <a:endParaRPr lang="en-US"/>
           </a:p>
@@ -3449,7 +3449,7 @@
           <a:p>
             <a:fld id="{E80C50CD-E178-4744-9B35-B2F624D6C5E9}" type="datetimeFigureOut">
               <a:rPr lang="en-US" smtClean="0"/>
-              <a:t>6/22/2026</a:t>
+              <a:t>6/23/2026</a:t>
             </a:fld>
             <a:endParaRPr lang="en-US"/>
           </a:p>
@@ -3699,7 +3699,7 @@
           <a:p>
             <a:fld id="{E80C50CD-E178-4744-9B35-B2F624D6C5E9}" type="datetimeFigureOut">
               <a:rPr lang="en-US" smtClean="0"/>
-              <a:t>6/22/2026</a:t>
+              <a:t>6/23/2026</a:t>
             </a:fld>
             <a:endParaRPr lang="en-US"/>
           </a:p>
@@ -3978,7 +3978,7 @@
           <a:p>
             <a:fld id="{E80C50CD-E178-4744-9B35-B2F624D6C5E9}" type="datetimeFigureOut">
               <a:rPr lang="en-US" smtClean="0"/>
-              <a:t>6/22/2026</a:t>
+              <a:t>6/23/2026</a:t>
             </a:fld>
             <a:endParaRPr lang="en-US"/>
           </a:p>
@@ -4295,7 +4295,7 @@
           <a:p>
             <a:fld id="{E80C50CD-E178-4744-9B35-B2F624D6C5E9}" type="datetimeFigureOut">
               <a:rPr lang="en-US" smtClean="0"/>
-              <a:t>6/22/2026</a:t>
+              <a:t>6/23/2026</a:t>
             </a:fld>
             <a:endParaRPr lang="en-US"/>
           </a:p>
@@ -4711,7 +4711,7 @@
           <a:p>
             <a:fld id="{E80C50CD-E178-4744-9B35-B2F624D6C5E9}" type="datetimeFigureOut">
               <a:rPr lang="en-US" smtClean="0"/>
-              <a:t>6/22/2026</a:t>
+              <a:t>6/23/2026</a:t>
             </a:fld>
             <a:endParaRPr lang="en-US"/>
           </a:p>
@@ -4852,7 +4852,7 @@
           <a:p>
             <a:fld id="{E80C50CD-E178-4744-9B35-B2F624D6C5E9}" type="datetimeFigureOut">
               <a:rPr lang="en-US" smtClean="0"/>
-              <a:t>6/22/2026</a:t>
+              <a:t>6/23/2026</a:t>
             </a:fld>
             <a:endParaRPr lang="en-US"/>
           </a:p>
@@ -4965,7 +4965,7 @@
           <a:p>
             <a:fld id="{E80C50CD-E178-4744-9B35-B2F624D6C5E9}" type="datetimeFigureOut">
               <a:rPr lang="en-US" smtClean="0"/>
-              <a:t>6/22/2026</a:t>
+              <a:t>6/23/2026</a:t>
             </a:fld>
             <a:endParaRPr lang="en-US"/>
           </a:p>
@@ -5282,7 +5282,7 @@
           <a:p>
             <a:fld id="{E80C50CD-E178-4744-9B35-B2F624D6C5E9}" type="datetimeFigureOut">
               <a:rPr lang="en-US" smtClean="0"/>
-              <a:t>6/22/2026</a:t>
+              <a:t>6/23/2026</a:t>
             </a:fld>
             <a:endParaRPr lang="en-US"/>
           </a:p>
@@ -5574,7 +5574,7 @@
           <a:p>
             <a:fld id="{E80C50CD-E178-4744-9B35-B2F624D6C5E9}" type="datetimeFigureOut">
               <a:rPr lang="en-US" smtClean="0"/>
-              <a:t>6/22/2026</a:t>
+              <a:t>6/23/2026</a:t>
             </a:fld>
             <a:endParaRPr lang="en-US"/>
           </a:p>
@@ -5814,7 +5814,7 @@
             <a:fld id="{E80C50CD-E178-4744-9B35-B2F624D6C5E9}" type="datetimeFigureOut">
               <a:rPr lang="en-US" smtClean="0"/>
               <a:pPr/>
-              <a:t>6/22/2026</a:t>
+              <a:t>6/23/2026</a:t>
             </a:fld>
             <a:endParaRPr lang="en-US"/>
           </a:p>
@@ -8899,9 +8899,10 @@
           <a:lstStyle/>
           <a:p>
             <a:r>
-              <a:rPr lang="fr-CH" dirty="0"/>
+              <a:rPr lang="fr-CH"/>
               <a:t>Pourquoi ce projet ?</a:t>
             </a:r>
+            <a:endParaRPr lang="fr-CH" dirty="0"/>
           </a:p>
         </p:txBody>
       </p:sp>
@@ -8990,6 +8991,36 @@
           </a:p>
         </p:txBody>
       </p:sp>
+      <p:pic>
+        <p:nvPicPr>
+          <p:cNvPr id="5" name="Image 4">
+            <a:extLst>
+              <a:ext uri="{FF2B5EF4-FFF2-40B4-BE49-F238E27FC236}">
+                <a16:creationId xmlns:a16="http://schemas.microsoft.com/office/drawing/2014/main" id="{4774EA8B-0F41-A1AA-4CA2-DC15A7D723CC}"/>
+              </a:ext>
+            </a:extLst>
+          </p:cNvPr>
+          <p:cNvPicPr>
+            <a:picLocks noChangeAspect="1"/>
+          </p:cNvPicPr>
+          <p:nvPr/>
+        </p:nvPicPr>
+        <p:blipFill>
+          <a:blip r:embed="rId2"/>
+          <a:stretch>
+            <a:fillRect/>
+          </a:stretch>
+        </p:blipFill>
+        <p:spPr>
+          <a:xfrm>
+            <a:off x="4198222" y="3012505"/>
+            <a:ext cx="7194880" cy="3513423"/>
+          </a:xfrm>
+          <a:prstGeom prst="rect">
+            <a:avLst/>
+          </a:prstGeom>
+        </p:spPr>
+      </p:pic>
     </p:spTree>
     <p:extLst>
       <p:ext uri="{BB962C8B-B14F-4D97-AF65-F5344CB8AC3E}">

</xml_diff>